<commit_message>
Update: Added Slide 12 (Sources) to presentation script and compiled PPTX with GitHub repository link
</commit_message>
<xml_diff>
--- a/Geopolitical_Oil_Research_Presentation.pptx
+++ b/Geopolitical_Oil_Research_Presentation.pptx
@@ -17,6 +17,7 @@
     <p:sldId id="265" r:id="rId17"/>
     <p:sldId id="266" r:id="rId18"/>
     <p:sldId id="267" r:id="rId19"/>
+    <p:sldId id="268" r:id="rId20"/>
   </p:sldIdLst>
   <p:sldSz cx="12188952" cy="6858000" type="screen4x3"/>
   <p:notesSz cx="6858000" cy="9144000"/>
@@ -724,6 +725,76 @@
           <a:p>
             <a:r>
               <a:t>To conclude, companies cannot control geopolitics, but they can control their exposure. Our main recommendation is to transition from reactive compliance to proactive structural resilience. This means checking supply chain chokepoint exposure today, formalizing a layered hedging program, and investing in the operational flexibility to process different grades of crude depending on where the market discounts lie. Thank you, and I am happy to open the floor to questions.</a:t>
+            </a:r>
+          </a:p>
+        </p:txBody>
+      </p:sp>
+      <p:sp>
+        <p:nvSpPr>
+          <p:cNvPr id="4" name="Slide Number Placeholder 3"/>
+          <p:cNvSpPr>
+            <a:spLocks noGrp="1"/>
+          </p:cNvSpPr>
+          <p:nvPr>
+            <p:ph type="sldNum" idx="5" sz="quarter"/>
+          </p:nvPr>
+        </p:nvSpPr>
+        <p:spPr/>
+      </p:sp>
+    </p:spTree>
+  </p:cSld>
+  <p:clrMapOvr>
+    <a:masterClrMapping/>
+  </p:clrMapOvr>
+</p:notes>
+</file>
+
+<file path=ppt/notesSlides/notesSlide13.xml><?xml version="1.0" encoding="utf-8"?>
+<p:notes xmlns:a="http://schemas.openxmlformats.org/drawingml/2006/main" xmlns:p="http://schemas.openxmlformats.org/presentationml/2006/main" xmlns:r="http://schemas.openxmlformats.org/officeDocument/2006/relationships">
+  <p:cSld>
+    <p:spTree>
+      <p:nvGrpSpPr>
+        <p:cNvPr id="1" name=""/>
+        <p:cNvGrpSpPr/>
+        <p:nvPr/>
+      </p:nvGrpSpPr>
+      <p:grpSpPr>
+        <a:xfrm>
+          <a:off x="0" y="0"/>
+          <a:ext cx="0" cy="0"/>
+          <a:chOff x="0" y="0"/>
+          <a:chExt cx="0" cy="0"/>
+        </a:xfrm>
+      </p:grpSpPr>
+      <p:sp>
+        <p:nvSpPr>
+          <p:cNvPr id="2" name="Slide Image Placeholder 1"/>
+          <p:cNvSpPr>
+            <a:spLocks noGrp="1"/>
+          </p:cNvSpPr>
+          <p:nvPr>
+            <p:ph type="sldImg" idx="2"/>
+          </p:nvPr>
+        </p:nvSpPr>
+        <p:spPr/>
+      </p:sp>
+      <p:sp>
+        <p:nvSpPr>
+          <p:cNvPr id="3" name="Notes Placeholder 2"/>
+          <p:cNvSpPr>
+            <a:spLocks noGrp="1"/>
+          </p:cNvSpPr>
+          <p:nvPr>
+            <p:ph type="body" idx="3" sz="quarter"/>
+          </p:nvPr>
+        </p:nvSpPr>
+        <p:spPr/>
+        <p:txBody>
+          <a:bodyPr/>
+          <a:lstStyle/>
+          <a:p>
+            <a:r>
+              <a:t>And finally, here is our data appendix and sources page. We have compiled all Brent crude price histories from the EIA and St. Louis Fed FRED databases, and mapped them to Indian ministry sourcing and trade datasets. Additionally, we have open-sourced the entire scraping codebase, charts, and CSV files in a public GitHub repository at the link shown here, allowing complete cross-verification of our research findings. Thank you very much.</a:t>
             </a:r>
           </a:p>
         </p:txBody>
@@ -5081,6 +5152,255 @@
             <a:br/>
             <a:r>
               <a:t>• For logistics/aviation, accelerate transition to energy-efficient assets and alternative fuels (e.g., Sustainable Aviation Fuel).</a:t>
+            </a:r>
+          </a:p>
+        </p:txBody>
+      </p:sp>
+    </p:spTree>
+  </p:cSld>
+  <p:clrMapOvr>
+    <a:masterClrMapping/>
+  </p:clrMapOvr>
+</p:sld>
+</file>
+
+<file path=ppt/slides/slide13.xml><?xml version="1.0" encoding="utf-8"?>
+<p:sld xmlns:a="http://schemas.openxmlformats.org/drawingml/2006/main" xmlns:p="http://schemas.openxmlformats.org/presentationml/2006/main" xmlns:r="http://schemas.openxmlformats.org/officeDocument/2006/relationships">
+  <p:cSld>
+    <p:bg>
+      <p:bgPr>
+        <a:solidFill>
+          <a:srgbClr val="FFFFFF"/>
+        </a:solidFill>
+        <a:effectLst/>
+      </p:bgPr>
+    </p:bg>
+    <p:spTree>
+      <p:nvGrpSpPr>
+        <p:cNvPr id="1" name=""/>
+        <p:cNvGrpSpPr/>
+        <p:nvPr/>
+      </p:nvGrpSpPr>
+      <p:grpSpPr/>
+      <p:pic>
+        <p:nvPicPr>
+          <p:cNvPr id="2" name="Picture 1" descr="iit_roorkee_logo.png"/>
+          <p:cNvPicPr>
+            <a:picLocks noChangeAspect="1"/>
+          </p:cNvPicPr>
+          <p:nvPr/>
+        </p:nvPicPr>
+        <p:blipFill>
+          <a:blip r:embed="rId2"/>
+          <a:stretch>
+            <a:fillRect/>
+          </a:stretch>
+        </p:blipFill>
+        <p:spPr>
+          <a:xfrm>
+            <a:off x="11091672" y="228600"/>
+            <a:ext cx="685800" cy="685800"/>
+          </a:xfrm>
+          <a:prstGeom prst="rect">
+            <a:avLst/>
+          </a:prstGeom>
+        </p:spPr>
+      </p:pic>
+      <p:sp>
+        <p:nvSpPr>
+          <p:cNvPr id="3" name="Rectangle 2"/>
+          <p:cNvSpPr/>
+          <p:nvPr/>
+        </p:nvSpPr>
+        <p:spPr>
+          <a:xfrm>
+            <a:off x="457200" y="1051560"/>
+            <a:ext cx="11274552" cy="18288"/>
+          </a:xfrm>
+          <a:prstGeom prst="rect">
+            <a:avLst/>
+          </a:prstGeom>
+          <a:solidFill>
+            <a:srgbClr val="DC2626"/>
+          </a:solidFill>
+          <a:ln>
+            <a:solidFill>
+              <a:srgbClr val="DC2626"/>
+            </a:solidFill>
+          </a:ln>
+        </p:spPr>
+        <p:style>
+          <a:lnRef idx="1">
+            <a:schemeClr val="accent1"/>
+          </a:lnRef>
+          <a:fillRef idx="3">
+            <a:schemeClr val="accent1"/>
+          </a:fillRef>
+          <a:effectRef idx="2">
+            <a:schemeClr val="accent1"/>
+          </a:effectRef>
+          <a:fontRef idx="minor">
+            <a:schemeClr val="lt1"/>
+          </a:fontRef>
+        </p:style>
+        <p:txBody>
+          <a:bodyPr rtlCol="0" anchor="ctr"/>
+          <a:lstStyle/>
+          <a:p>
+            <a:pPr algn="ctr"/>
+          </a:p>
+        </p:txBody>
+      </p:sp>
+      <p:sp>
+        <p:nvSpPr>
+          <p:cNvPr id="4" name="TextBox 3"/>
+          <p:cNvSpPr txBox="1"/>
+          <p:nvPr/>
+        </p:nvSpPr>
+        <p:spPr>
+          <a:xfrm>
+            <a:off x="457200" y="320040"/>
+            <a:ext cx="9144000" cy="731520"/>
+          </a:xfrm>
+          <a:prstGeom prst="rect">
+            <a:avLst/>
+          </a:prstGeom>
+          <a:noFill/>
+        </p:spPr>
+        <p:txBody>
+          <a:bodyPr wrap="square" lIns="0" tIns="0">
+            <a:spAutoFit/>
+          </a:bodyPr>
+          <a:lstStyle/>
+          <a:p>
+            <a:pPr>
+              <a:defRPr sz="2800" b="1">
+                <a:solidFill>
+                  <a:srgbClr val="0F172A"/>
+                </a:solidFill>
+                <a:latin typeface="Arial"/>
+              </a:defRPr>
+            </a:pPr>
+            <a:r>
+              <a:t>Sources &amp; Data Appendix</a:t>
+            </a:r>
+          </a:p>
+        </p:txBody>
+      </p:sp>
+      <p:sp>
+        <p:nvSpPr>
+          <p:cNvPr id="5" name="TextBox 4"/>
+          <p:cNvSpPr txBox="1"/>
+          <p:nvPr/>
+        </p:nvSpPr>
+        <p:spPr>
+          <a:xfrm>
+            <a:off x="457200" y="1280160"/>
+            <a:ext cx="11274552" cy="4754880"/>
+          </a:xfrm>
+          <a:prstGeom prst="rect">
+            <a:avLst/>
+          </a:prstGeom>
+          <a:noFill/>
+        </p:spPr>
+        <p:txBody>
+          <a:bodyPr wrap="square" lIns="0">
+            <a:spAutoFit/>
+          </a:bodyPr>
+          <a:lstStyle/>
+          <a:p>
+            <a:pPr>
+              <a:lnSpc>
+                <a:spcPct val="120000"/>
+              </a:lnSpc>
+              <a:spcAft>
+                <a:spcPts val="1400"/>
+              </a:spcAft>
+              <a:defRPr sz="1500">
+                <a:solidFill>
+                  <a:srgbClr val="334155"/>
+                </a:solidFill>
+                <a:latin typeface="Arial"/>
+              </a:defRPr>
+            </a:pPr>
+            <a:r>
+              <a:t>• Brent Crude Spot Prices &amp; Historical Volatility: U.S. Energy Information Administration (EIA) Spot Prices &amp; St. Louis Fed (FRED) Database - Series DCOILBRENTEU</a:t>
+            </a:r>
+          </a:p>
+          <a:p>
+            <a:pPr>
+              <a:lnSpc>
+                <a:spcPct val="120000"/>
+              </a:lnSpc>
+              <a:spcAft>
+                <a:spcPts val="1400"/>
+              </a:spcAft>
+              <a:defRPr sz="1500">
+                <a:solidFill>
+                  <a:srgbClr val="334155"/>
+                </a:solidFill>
+                <a:latin typeface="Arial"/>
+              </a:defRPr>
+            </a:pPr>
+            <a:r>
+              <a:t>• Indian Crude Sourcing &amp; Import Statistics: Ministry of Petroleum &amp; Natural Gas (PPAC) &amp; Ministry of Commerce &amp; Industry (TRADESTAT database)</a:t>
+            </a:r>
+          </a:p>
+          <a:p>
+            <a:pPr>
+              <a:lnSpc>
+                <a:spcPct val="120000"/>
+              </a:lnSpc>
+              <a:spcAft>
+                <a:spcPts val="1400"/>
+              </a:spcAft>
+              <a:defRPr sz="1500">
+                <a:solidFill>
+                  <a:srgbClr val="334155"/>
+                </a:solidFill>
+                <a:latin typeface="Arial"/>
+              </a:defRPr>
+            </a:pPr>
+            <a:r>
+              <a:t>• Maritime Chokepoints &amp; Logistics Economics: EIA World Oil Transit Chokepoints Brief &amp; UNCTAD Reports on Red Sea Navigation Disruptions (2024-2026)</a:t>
+            </a:r>
+          </a:p>
+          <a:p>
+            <a:pPr>
+              <a:lnSpc>
+                <a:spcPct val="120000"/>
+              </a:lnSpc>
+              <a:spcAft>
+                <a:spcPts val="1400"/>
+              </a:spcAft>
+              <a:defRPr sz="1500">
+                <a:solidFill>
+                  <a:srgbClr val="334155"/>
+                </a:solidFill>
+                <a:latin typeface="Arial"/>
+              </a:defRPr>
+            </a:pPr>
+            <a:r>
+              <a:t>• Aviation Industry &amp; Sanctions Frameworks: IATA Jet Fuel Price Monitor &amp; G7 Price Cap Coalition Advisories (U.S. Treasury OFAC)</a:t>
+            </a:r>
+          </a:p>
+          <a:p>
+            <a:pPr>
+              <a:lnSpc>
+                <a:spcPct val="120000"/>
+              </a:lnSpc>
+              <a:spcAft>
+                <a:spcPts val="1400"/>
+              </a:spcAft>
+              <a:defRPr sz="1500">
+                <a:solidFill>
+                  <a:srgbClr val="334155"/>
+                </a:solidFill>
+                <a:latin typeface="Arial"/>
+              </a:defRPr>
+            </a:pPr>
+            <a:r>
+              <a:t>• Interactive Data Appendix &amp; Python Source Code: Verification repository and script automation is hosted at: https://github.com/jozee-io/oil-geopolitics-2022-2026</a:t>
             </a:r>
           </a:p>
         </p:txBody>

</xml_diff>